<commit_message>
Thai Calendar: Thai language, Buddhist Era, 2026/2027 holidays, notes, notifications, v1.0.0
</commit_message>
<xml_diff>
--- a/store listing/New Microsoft PowerPoint Presentation.pptx
+++ b/store listing/New Microsoft PowerPoint Presentation.pptx
@@ -9,7 +9,8 @@
     <p:sldId id="257" r:id="rId3"/>
     <p:sldId id="258" r:id="rId4"/>
     <p:sldId id="260" r:id="rId5"/>
-    <p:sldId id="259" r:id="rId6"/>
+    <p:sldId id="261" r:id="rId6"/>
+    <p:sldId id="259" r:id="rId7"/>
   </p:sldIdLst>
   <p:sldSz cx="12192000" cy="6858000"/>
   <p:notesSz cx="6858000" cy="9144000"/>
@@ -265,7 +266,7 @@
           <a:p>
             <a:fld id="{E1E9AC80-D11F-4B3A-9E73-1AA080555D2B}" type="datetimeFigureOut">
               <a:rPr lang="en-AU" smtClean="0"/>
-              <a:t>27/01/2026</a:t>
+              <a:t>29/01/2026</a:t>
             </a:fld>
             <a:endParaRPr lang="en-AU"/>
           </a:p>
@@ -465,7 +466,7 @@
           <a:p>
             <a:fld id="{E1E9AC80-D11F-4B3A-9E73-1AA080555D2B}" type="datetimeFigureOut">
               <a:rPr lang="en-AU" smtClean="0"/>
-              <a:t>27/01/2026</a:t>
+              <a:t>29/01/2026</a:t>
             </a:fld>
             <a:endParaRPr lang="en-AU"/>
           </a:p>
@@ -675,7 +676,7 @@
           <a:p>
             <a:fld id="{E1E9AC80-D11F-4B3A-9E73-1AA080555D2B}" type="datetimeFigureOut">
               <a:rPr lang="en-AU" smtClean="0"/>
-              <a:t>27/01/2026</a:t>
+              <a:t>29/01/2026</a:t>
             </a:fld>
             <a:endParaRPr lang="en-AU"/>
           </a:p>
@@ -875,7 +876,7 @@
           <a:p>
             <a:fld id="{E1E9AC80-D11F-4B3A-9E73-1AA080555D2B}" type="datetimeFigureOut">
               <a:rPr lang="en-AU" smtClean="0"/>
-              <a:t>27/01/2026</a:t>
+              <a:t>29/01/2026</a:t>
             </a:fld>
             <a:endParaRPr lang="en-AU"/>
           </a:p>
@@ -1151,7 +1152,7 @@
           <a:p>
             <a:fld id="{E1E9AC80-D11F-4B3A-9E73-1AA080555D2B}" type="datetimeFigureOut">
               <a:rPr lang="en-AU" smtClean="0"/>
-              <a:t>27/01/2026</a:t>
+              <a:t>29/01/2026</a:t>
             </a:fld>
             <a:endParaRPr lang="en-AU"/>
           </a:p>
@@ -1419,7 +1420,7 @@
           <a:p>
             <a:fld id="{E1E9AC80-D11F-4B3A-9E73-1AA080555D2B}" type="datetimeFigureOut">
               <a:rPr lang="en-AU" smtClean="0"/>
-              <a:t>27/01/2026</a:t>
+              <a:t>29/01/2026</a:t>
             </a:fld>
             <a:endParaRPr lang="en-AU"/>
           </a:p>
@@ -1834,7 +1835,7 @@
           <a:p>
             <a:fld id="{E1E9AC80-D11F-4B3A-9E73-1AA080555D2B}" type="datetimeFigureOut">
               <a:rPr lang="en-AU" smtClean="0"/>
-              <a:t>27/01/2026</a:t>
+              <a:t>29/01/2026</a:t>
             </a:fld>
             <a:endParaRPr lang="en-AU"/>
           </a:p>
@@ -1976,7 +1977,7 @@
           <a:p>
             <a:fld id="{E1E9AC80-D11F-4B3A-9E73-1AA080555D2B}" type="datetimeFigureOut">
               <a:rPr lang="en-AU" smtClean="0"/>
-              <a:t>27/01/2026</a:t>
+              <a:t>29/01/2026</a:t>
             </a:fld>
             <a:endParaRPr lang="en-AU"/>
           </a:p>
@@ -2089,7 +2090,7 @@
           <a:p>
             <a:fld id="{E1E9AC80-D11F-4B3A-9E73-1AA080555D2B}" type="datetimeFigureOut">
               <a:rPr lang="en-AU" smtClean="0"/>
-              <a:t>27/01/2026</a:t>
+              <a:t>29/01/2026</a:t>
             </a:fld>
             <a:endParaRPr lang="en-AU"/>
           </a:p>
@@ -2402,7 +2403,7 @@
           <a:p>
             <a:fld id="{E1E9AC80-D11F-4B3A-9E73-1AA080555D2B}" type="datetimeFigureOut">
               <a:rPr lang="en-AU" smtClean="0"/>
-              <a:t>27/01/2026</a:t>
+              <a:t>29/01/2026</a:t>
             </a:fld>
             <a:endParaRPr lang="en-AU"/>
           </a:p>
@@ -2691,7 +2692,7 @@
           <a:p>
             <a:fld id="{E1E9AC80-D11F-4B3A-9E73-1AA080555D2B}" type="datetimeFigureOut">
               <a:rPr lang="en-AU" smtClean="0"/>
-              <a:t>27/01/2026</a:t>
+              <a:t>29/01/2026</a:t>
             </a:fld>
             <a:endParaRPr lang="en-AU"/>
           </a:p>
@@ -2934,7 +2935,7 @@
           <a:p>
             <a:fld id="{E1E9AC80-D11F-4B3A-9E73-1AA080555D2B}" type="datetimeFigureOut">
               <a:rPr lang="en-AU" smtClean="0"/>
-              <a:t>27/01/2026</a:t>
+              <a:t>29/01/2026</a:t>
             </a:fld>
             <a:endParaRPr lang="en-AU"/>
           </a:p>
@@ -4389,6 +4390,268 @@
 </file>
 
 <file path=ppt/slides/slide5.xml><?xml version="1.0" encoding="utf-8"?>
+<p:sld xmlns:a="http://schemas.openxmlformats.org/drawingml/2006/main" xmlns:r="http://schemas.openxmlformats.org/officeDocument/2006/relationships" xmlns:p="http://schemas.openxmlformats.org/presentationml/2006/main">
+  <p:cSld>
+    <p:spTree>
+      <p:nvGrpSpPr>
+        <p:cNvPr id="1" name="">
+          <a:extLst>
+            <a:ext uri="{FF2B5EF4-FFF2-40B4-BE49-F238E27FC236}">
+              <a16:creationId xmlns:a16="http://schemas.microsoft.com/office/drawing/2014/main" id="{981AAFCF-B22F-2884-5488-5EEF69D7483C}"/>
+            </a:ext>
+          </a:extLst>
+        </p:cNvPr>
+        <p:cNvGrpSpPr/>
+        <p:nvPr/>
+      </p:nvGrpSpPr>
+      <p:grpSpPr>
+        <a:xfrm>
+          <a:off x="0" y="0"/>
+          <a:ext cx="0" cy="0"/>
+          <a:chOff x="0" y="0"/>
+          <a:chExt cx="0" cy="0"/>
+        </a:xfrm>
+      </p:grpSpPr>
+      <p:grpSp>
+        <p:nvGrpSpPr>
+          <p:cNvPr id="16" name="Group 15">
+            <a:extLst>
+              <a:ext uri="{FF2B5EF4-FFF2-40B4-BE49-F238E27FC236}">
+                <a16:creationId xmlns:a16="http://schemas.microsoft.com/office/drawing/2014/main" id="{A4EE6E39-3B7B-7D15-FA11-F4B45D8D2C2F}"/>
+              </a:ext>
+            </a:extLst>
+          </p:cNvPr>
+          <p:cNvGrpSpPr/>
+          <p:nvPr/>
+        </p:nvGrpSpPr>
+        <p:grpSpPr>
+          <a:xfrm>
+            <a:off x="1152940" y="1327868"/>
+            <a:ext cx="9739394" cy="4575498"/>
+            <a:chOff x="1152939" y="1327868"/>
+            <a:chExt cx="10098157" cy="4182386"/>
+          </a:xfrm>
+        </p:grpSpPr>
+        <p:grpSp>
+          <p:nvGrpSpPr>
+            <p:cNvPr id="4" name="Group 3">
+              <a:extLst>
+                <a:ext uri="{FF2B5EF4-FFF2-40B4-BE49-F238E27FC236}">
+                  <a16:creationId xmlns:a16="http://schemas.microsoft.com/office/drawing/2014/main" id="{EC3CBBB2-FF55-3A5F-46B5-0D8575317E0A}"/>
+                </a:ext>
+              </a:extLst>
+            </p:cNvPr>
+            <p:cNvGrpSpPr/>
+            <p:nvPr/>
+          </p:nvGrpSpPr>
+          <p:grpSpPr>
+            <a:xfrm>
+              <a:off x="1152939" y="1327868"/>
+              <a:ext cx="10098157" cy="4182386"/>
+              <a:chOff x="1152939" y="1327868"/>
+              <a:chExt cx="10098157" cy="4182386"/>
+            </a:xfrm>
+          </p:grpSpPr>
+          <p:sp>
+            <p:nvSpPr>
+              <p:cNvPr id="5" name="Rectangle 4">
+                <a:extLst>
+                  <a:ext uri="{FF2B5EF4-FFF2-40B4-BE49-F238E27FC236}">
+                    <a16:creationId xmlns:a16="http://schemas.microsoft.com/office/drawing/2014/main" id="{6825A735-D8F2-1C83-55AE-57B3277CF5A0}"/>
+                  </a:ext>
+                </a:extLst>
+              </p:cNvPr>
+              <p:cNvSpPr/>
+              <p:nvPr/>
+            </p:nvSpPr>
+            <p:spPr>
+              <a:xfrm>
+                <a:off x="1152939" y="1327868"/>
+                <a:ext cx="10098157" cy="4182386"/>
+              </a:xfrm>
+              <a:prstGeom prst="rect">
+                <a:avLst/>
+              </a:prstGeom>
+              <a:solidFill>
+                <a:schemeClr val="bg1">
+                  <a:lumMod val="95000"/>
+                </a:schemeClr>
+              </a:solidFill>
+            </p:spPr>
+            <p:style>
+              <a:lnRef idx="2">
+                <a:schemeClr val="accent1">
+                  <a:shade val="15000"/>
+                </a:schemeClr>
+              </a:lnRef>
+              <a:fillRef idx="1">
+                <a:schemeClr val="accent1"/>
+              </a:fillRef>
+              <a:effectRef idx="0">
+                <a:schemeClr val="accent1"/>
+              </a:effectRef>
+              <a:fontRef idx="minor">
+                <a:schemeClr val="lt1"/>
+              </a:fontRef>
+            </p:style>
+            <p:txBody>
+              <a:bodyPr rtlCol="0" anchor="ctr"/>
+              <a:lstStyle/>
+              <a:p>
+                <a:pPr algn="ctr"/>
+                <a:endParaRPr lang="en-AU" dirty="0">
+                  <a:solidFill>
+                    <a:schemeClr val="tx1"/>
+                  </a:solidFill>
+                </a:endParaRPr>
+              </a:p>
+            </p:txBody>
+          </p:sp>
+          <p:sp>
+            <p:nvSpPr>
+              <p:cNvPr id="7" name="TextBox 6">
+                <a:extLst>
+                  <a:ext uri="{FF2B5EF4-FFF2-40B4-BE49-F238E27FC236}">
+                    <a16:creationId xmlns:a16="http://schemas.microsoft.com/office/drawing/2014/main" id="{362EA120-5D8B-67DD-D8E4-91F0403BFE01}"/>
+                  </a:ext>
+                </a:extLst>
+              </p:cNvPr>
+              <p:cNvSpPr txBox="1"/>
+              <p:nvPr/>
+            </p:nvSpPr>
+            <p:spPr>
+              <a:xfrm>
+                <a:off x="4769616" y="1436768"/>
+                <a:ext cx="6269445" cy="4047262"/>
+              </a:xfrm>
+              <a:prstGeom prst="rect">
+                <a:avLst/>
+              </a:prstGeom>
+              <a:noFill/>
+            </p:spPr>
+            <p:txBody>
+              <a:bodyPr wrap="square" rtlCol="0">
+                <a:spAutoFit/>
+              </a:bodyPr>
+              <a:lstStyle/>
+              <a:p>
+                <a:pPr algn="ctr"/>
+                <a:r>
+                  <a:rPr lang="en-AU" sz="2400" b="1" dirty="0"/>
+                  <a:t>Thai Calendar</a:t>
+                </a:r>
+                <a:endParaRPr lang="en-AU" sz="2400" b="1" u="sng" dirty="0"/>
+              </a:p>
+              <a:p>
+                <a:pPr algn="ctr"/>
+                <a:r>
+                  <a:rPr lang="en-US" sz="1300" dirty="0"/>
+                  <a:t>This app is a complete calendar that includes all public holidays and important days for Thailand for 2026 and 2027, with the option to display years in Buddhist Era (BE) or Christian Era (AD).</a:t>
+                </a:r>
+              </a:p>
+              <a:p>
+                <a:r>
+                  <a:rPr lang="en-US" sz="1600" b="1" dirty="0"/>
+                  <a:t>Key features:</a:t>
+                </a:r>
+                <a:endParaRPr lang="en-US" sz="1600" dirty="0"/>
+              </a:p>
+              <a:p>
+                <a:r>
+                  <a:rPr lang="en-US" sz="1300" dirty="0"/>
+                  <a:t>• Public holidays – All official Thai public holidays for 2026 and 2027, including New Year's Day, Songkran, Chakri Day, Coronation Day, Father's Day, Constitution Day, and Buddhist holidays (Makha Bucha, Visakha Bucha, </a:t>
+                </a:r>
+                <a:r>
+                  <a:rPr lang="en-US" sz="1300" dirty="0" err="1"/>
+                  <a:t>Asalha</a:t>
+                </a:r>
+                <a:r>
+                  <a:rPr lang="en-US" sz="1300" dirty="0"/>
+                  <a:t> Puja, Buddhist Lent).</a:t>
+                </a:r>
+              </a:p>
+              <a:p>
+                <a:r>
+                  <a:rPr lang="en-US" sz="1300" dirty="0"/>
+                  <a:t>• Thai &amp; English – Use the app in Thai or English; holiday names are shown in the language you choose.</a:t>
+                </a:r>
+              </a:p>
+              <a:p>
+                <a:r>
+                  <a:rPr lang="en-US" sz="1300" dirty="0"/>
+                  <a:t>• Buddhist Era (BE) or Christian Era (AD) – Choose how years are displayed in Settings; year view shows all 12 months at a glance; month view highlights holidays clearly.</a:t>
+                </a:r>
+              </a:p>
+              <a:p>
+                <a:r>
+                  <a:rPr lang="en-US" sz="1300" dirty="0"/>
+                  <a:t>• My Notes – Add notes for any day, repeat yearly, and set reminders.</a:t>
+                </a:r>
+              </a:p>
+              <a:p>
+                <a:r>
+                  <a:rPr lang="en-US" sz="1300" dirty="0"/>
+                  <a:t>• Holiday reminders &amp; themes – Get notified before holidays (e.g. 1 day before, at your chosen time); light, dark, or system theme.</a:t>
+                </a:r>
+              </a:p>
+              <a:p>
+                <a:endParaRPr lang="en-US" sz="1200" dirty="0"/>
+              </a:p>
+              <a:p>
+                <a:pPr algn="ctr"/>
+                <a:r>
+                  <a:rPr lang="en-US" b="1" dirty="0"/>
+                  <a:t>Thai Calendar helps you plan your daily activities and stay informed about public holidays in Thailand.</a:t>
+                </a:r>
+              </a:p>
+            </p:txBody>
+          </p:sp>
+        </p:grpSp>
+        <p:pic>
+          <p:nvPicPr>
+            <p:cNvPr id="15" name="Picture 14">
+              <a:extLst>
+                <a:ext uri="{FF2B5EF4-FFF2-40B4-BE49-F238E27FC236}">
+                  <a16:creationId xmlns:a16="http://schemas.microsoft.com/office/drawing/2014/main" id="{3465C549-DEC9-F7B6-A565-2DC216461997}"/>
+                </a:ext>
+              </a:extLst>
+            </p:cNvPr>
+            <p:cNvPicPr>
+              <a:picLocks noChangeAspect="1"/>
+            </p:cNvPicPr>
+            <p:nvPr/>
+          </p:nvPicPr>
+          <p:blipFill>
+            <a:blip r:embed="rId2"/>
+            <a:stretch>
+              <a:fillRect/>
+            </a:stretch>
+          </p:blipFill>
+          <p:spPr>
+            <a:xfrm>
+              <a:off x="1417596" y="1861211"/>
+              <a:ext cx="3195667" cy="3115700"/>
+            </a:xfrm>
+            <a:prstGeom prst="rect">
+              <a:avLst/>
+            </a:prstGeom>
+          </p:spPr>
+        </p:pic>
+      </p:grpSp>
+    </p:spTree>
+    <p:extLst>
+      <p:ext uri="{BB962C8B-B14F-4D97-AF65-F5344CB8AC3E}">
+        <p14:creationId xmlns:p14="http://schemas.microsoft.com/office/powerpoint/2010/main" val="522383449"/>
+      </p:ext>
+    </p:extLst>
+  </p:cSld>
+  <p:clrMapOvr>
+    <a:masterClrMapping/>
+  </p:clrMapOvr>
+</p:sld>
+</file>
+
+<file path=ppt/slides/slide6.xml><?xml version="1.0" encoding="utf-8"?>
 <p:sld xmlns:a="http://schemas.openxmlformats.org/drawingml/2006/main" xmlns:r="http://schemas.openxmlformats.org/officeDocument/2006/relationships" xmlns:p="http://schemas.openxmlformats.org/presentationml/2006/main">
   <p:cSld>
     <p:spTree>

</xml_diff>